<commit_message>
Medical/NIPER cluster rules, dashboard deep links and label fixes
</commit_message>
<xml_diff>
--- a/outputs/report/group29_report.pptx
+++ b/outputs/report/group29_report.pptx
@@ -2522,25 +2522,25 @@
               <c:strCache>
                 <c:ptCount val="8"/>
                 <c:pt idx="0">
-                  <c:v>CSIR – IISc/TIFR/IISER</c:v>
+                  <c:v>CSIR – IIT</c:v>
                 </c:pt>
                 <c:pt idx="1">
-                  <c:v>CSIR – IIT</c:v>
+                  <c:v>CSIR – Government</c:v>
                 </c:pt>
                 <c:pt idx="2">
-                  <c:v>CSIR – Government</c:v>
+                  <c:v>CSIR – NIPER</c:v>
                 </c:pt>
                 <c:pt idx="3">
+                  <c:v>CSIR – Other</c:v>
+                </c:pt>
+                <c:pt idx="4">
                   <c:v>CSIR – Central University</c:v>
                 </c:pt>
-                <c:pt idx="4">
-                  <c:v>CSIR – Other</c:v>
-                </c:pt>
                 <c:pt idx="5">
+                  <c:v>CSIR – CSIR</c:v>
+                </c:pt>
+                <c:pt idx="6">
                   <c:v>CSIR – Medical</c:v>
-                </c:pt>
-                <c:pt idx="6">
-                  <c:v>CSIR – CSIR</c:v>
                 </c:pt>
                 <c:pt idx="7">
                   <c:v>CSIR – University (other)</c:v>
@@ -2555,28 +2555,28 @@
                 <c:formatCode>General</c:formatCode>
                 <c:ptCount val="8"/>
                 <c:pt idx="0">
-                  <c:v>242</c:v>
+                  <c:v>295</c:v>
                 </c:pt>
                 <c:pt idx="1">
-                  <c:v>295</c:v>
+                  <c:v>325</c:v>
                 </c:pt>
                 <c:pt idx="2">
-                  <c:v>458</c:v>
+                  <c:v>423</c:v>
                 </c:pt>
                 <c:pt idx="3">
+                  <c:v>584</c:v>
+                </c:pt>
+                <c:pt idx="4">
                   <c:v>650</c:v>
                 </c:pt>
-                <c:pt idx="4">
-                  <c:v>660</c:v>
-                </c:pt>
                 <c:pt idx="5">
-                  <c:v>1053</c:v>
+                  <c:v>1065</c:v>
                 </c:pt>
                 <c:pt idx="6">
-                  <c:v>1065</c:v>
+                  <c:v>1426</c:v>
                 </c:pt>
                 <c:pt idx="7">
-                  <c:v>2157</c:v>
+                  <c:v>1570</c:v>
                 </c:pt>
               </c:numCache>
             </c:numRef>
@@ -7221,7 +7221,7 @@
                 </a:solidFill>
                 <a:latin typeface="Calibri"/>
               </a:rPr>
-              <a:t>Strongest ties outside CSIR: University (other) (2,157 papers), Medical (1,053 papers), Central University (650 papers).</a:t>
+              <a:t>Strongest ties outside CSIR: University (other) (1,570 papers), Medical (1,426 papers), Central University (650 papers).</a:t>
             </a:r>
           </a:p>
           <a:p>

</xml_diff>